<commit_message>
docs: 「Microsoft 365 Copilot Recap」→「Copilot Recap」に短縮
口語ナレーションで「マイクロソフトサンロクゴコパイロットリキャップは〜」が
長くて固いという指摘。スライドカード見出し・S2 ナレーション・スピーカーノート・
YouTube 説明文すべてで「Copilot Recap」表記に統一。

Co-Authored-By: Claude Opus 4.7 (1M context) <noreply@anthropic.com>
</commit_message>
<xml_diff>
--- a/articles/mochi-kiki-teams-agent/video/mochi-kiki-demo-deck.pptx
+++ b/articles/mochi-kiki-teams-agent/video/mochi-kiki-demo-deck.pptx
@@ -880,7 +880,7 @@
             <a:r>
               <a:rPr lang="en-US" dirty="0"/>
               <a:t>[0:15–0:30 / 15 秒]
-Microsoft 365 Copilot Recap は、会議後の要約や Action 抽出は十分まかなえます。
+Copilot Recap は、会議後の要約や Action 抽出は十分まかなえます。
 ただ、会議の最中には動きません。
 会議中の用語確認や、認識合わせは、別の仕組みが要ります。</a:t>
             </a:r>
@@ -4784,7 +4784,7 @@
                 <a:ea typeface="Helvetica Neue" pitchFamily="34" charset="-122"/>
                 <a:cs typeface="Helvetica Neue" pitchFamily="34" charset="-120"/>
               </a:rPr>
-              <a:t>Microsoft 365 Copilot Recap</a:t>
+              <a:t>Copilot Recap</a:t>
             </a:r>
             <a:endParaRPr lang="en-US" sz="1200" dirty="0"/>
           </a:p>

</xml_diff>

<commit_message>
fix: 「Copilot Recap」→ 公式名称「Intelligent Recap」に修正
Microsoft 公式ドキュメントを確認したところ「Copilot Recap」という単独製品名は
存在しない。AI 要約+アクション抽出を行う会議後機能の正式名称は
「Intelligent Recap」(Microsoft 365 Copilot または Teams Premium で利用可)。

出典: https://learn.microsoft.com/microsoftteams/intelligent-recap-calls-meetings

修正範囲: スライドカード見出し / 録音ナレーション / スピーカーノート /
YouTube 説明文・チャプター / 記事本文 (draft.md) を全て公式名称に統一。
記事には Microsoft Learn へのリンクも追加し、提出時の根拠を担保。

Co-Authored-By: Claude Opus 4.7 (1M context) <noreply@anthropic.com>
</commit_message>
<xml_diff>
--- a/articles/mochi-kiki-teams-agent/video/mochi-kiki-demo-deck.pptx
+++ b/articles/mochi-kiki-teams-agent/video/mochi-kiki-demo-deck.pptx
@@ -880,7 +880,7 @@
             <a:r>
               <a:rPr lang="en-US" dirty="0"/>
               <a:t>[0:15–0:30 / 15 秒]
-Copilot Recap は、会議後の要約や Action 抽出は十分まかなえます。
+Intelligent Recap は、会議後の要約や Action 抽出は十分まかなえます。
 ただ、会議の最中には動きません。
 会議中の用語確認や、認識合わせは、別の仕組みが要ります。</a:t>
             </a:r>
@@ -4784,7 +4784,7 @@
                 <a:ea typeface="Helvetica Neue" pitchFamily="34" charset="-122"/>
                 <a:cs typeface="Helvetica Neue" pitchFamily="34" charset="-120"/>
               </a:rPr>
-              <a:t>Copilot Recap</a:t>
+              <a:t>Intelligent Recap</a:t>
             </a:r>
             <a:endParaRPr lang="en-US" sz="1200" dirty="0"/>
           </a:p>

</xml_diff>